<commit_message>
Fix author name: use 'Surya Nalluri' throughout all three deliverables
Remove '· Aluri' suffix from leadership text in:
- docs/OSSPolicyGuard_Requirements_Tracker.xlsx (1 cell)
- docs/OSSPolicyGuard_Dev_Guide.pptx (13 slide XML files)
- docs/OSSPolicyGuard_Business_Overview.pptx (14 slide XML files)
</commit_message>
<xml_diff>
--- a/docs/OSSPolicyGuard_Business_Overview.pptx
+++ b/docs/OSSPolicyGuard_Business_Overview.pptx
@@ -2200,7 +2200,7 @@
                 <a:ea typeface="Calibri" pitchFamily="34" charset="-122"/>
                 <a:cs typeface="Calibri" pitchFamily="34" charset="-120"/>
               </a:rPr>
-              <a:t>Surya Nalluri · Aluri</a:t>
+              <a:t>Surya Nalluri</a:t>
             </a:r>
             <a:endParaRPr lang="en-US" sz="1300" dirty="0"/>
           </a:p>
@@ -2367,7 +2367,7 @@
                 <a:ea typeface="Calibri" pitchFamily="34" charset="-122"/>
                 <a:cs typeface="Calibri" pitchFamily="34" charset="-120"/>
               </a:rPr>
-              <a:t>Surya Nalluri · Aluri</a:t>
+              <a:t>Surya Nalluri</a:t>
             </a:r>
             <a:endParaRPr lang="en-US" sz="900" dirty="0"/>
           </a:p>
@@ -6758,7 +6758,7 @@
                 <a:ea typeface="Calibri" pitchFamily="34" charset="-122"/>
                 <a:cs typeface="Calibri" pitchFamily="34" charset="-120"/>
               </a:rPr>
-              <a:t>Surya Nalluri · Aluri</a:t>
+              <a:t>Surya Nalluri</a:t>
             </a:r>
             <a:endParaRPr lang="en-US" sz="900" dirty="0"/>
           </a:p>
@@ -7383,7 +7383,7 @@
                 <a:ea typeface="Calibri" pitchFamily="34" charset="-122"/>
                 <a:cs typeface="Calibri" pitchFamily="34" charset="-120"/>
               </a:rPr>
-              <a:t>Surya Nalluri · Aluri</a:t>
+              <a:t>Surya Nalluri</a:t>
             </a:r>
             <a:endParaRPr lang="en-US" sz="900" dirty="0"/>
           </a:p>
@@ -8516,7 +8516,7 @@
                 <a:ea typeface="Calibri" pitchFamily="34" charset="-122"/>
                 <a:cs typeface="Calibri" pitchFamily="34" charset="-120"/>
               </a:rPr>
-              <a:t>Surya Nalluri · Aluri</a:t>
+              <a:t>Surya Nalluri</a:t>
             </a:r>
             <a:endParaRPr lang="en-US" sz="900" dirty="0"/>
           </a:p>
@@ -9321,7 +9321,7 @@
                 <a:ea typeface="Calibri" pitchFamily="34" charset="-122"/>
                 <a:cs typeface="Calibri" pitchFamily="34" charset="-120"/>
               </a:rPr>
-              <a:t>Surya Nalluri · Aluri</a:t>
+              <a:t>Surya Nalluri</a:t>
             </a:r>
             <a:endParaRPr lang="en-US" sz="1400" dirty="0"/>
           </a:p>
@@ -9488,7 +9488,7 @@
                 <a:ea typeface="Calibri" pitchFamily="34" charset="-122"/>
                 <a:cs typeface="Calibri" pitchFamily="34" charset="-120"/>
               </a:rPr>
-              <a:t>Surya Nalluri · Aluri</a:t>
+              <a:t>Surya Nalluri</a:t>
             </a:r>
             <a:endParaRPr lang="en-US" sz="900" dirty="0"/>
           </a:p>
@@ -10105,7 +10105,7 @@
                 <a:ea typeface="Calibri" pitchFamily="34" charset="-122"/>
                 <a:cs typeface="Calibri" pitchFamily="34" charset="-120"/>
               </a:rPr>
-              <a:t>Surya Nalluri · Aluri</a:t>
+              <a:t>Surya Nalluri</a:t>
             </a:r>
             <a:endParaRPr lang="en-US" sz="900" dirty="0"/>
           </a:p>
@@ -11367,7 +11367,7 @@
                 <a:ea typeface="Calibri" pitchFamily="34" charset="-122"/>
                 <a:cs typeface="Calibri" pitchFamily="34" charset="-120"/>
               </a:rPr>
-              <a:t>Surya Nalluri · Aluri</a:t>
+              <a:t>Surya Nalluri</a:t>
             </a:r>
             <a:endParaRPr lang="en-US" sz="900" dirty="0"/>
           </a:p>
@@ -11495,7 +11495,7 @@
                 <a:ea typeface="Calibri" pitchFamily="34" charset="-122"/>
                 <a:cs typeface="Calibri" pitchFamily="34" charset="-120"/>
               </a:rPr>
-              <a:t>Surya Nalluri · Aluri</a:t>
+              <a:t>Surya Nalluri</a:t>
             </a:r>
             <a:endParaRPr lang="en-US" sz="900" dirty="0"/>
           </a:p>
@@ -12831,7 +12831,7 @@
                 <a:ea typeface="Calibri" pitchFamily="34" charset="-122"/>
                 <a:cs typeface="Calibri" pitchFamily="34" charset="-120"/>
               </a:rPr>
-              <a:t>Surya Nalluri · Aluri</a:t>
+              <a:t>Surya Nalluri</a:t>
             </a:r>
             <a:endParaRPr lang="en-US" sz="900" dirty="0"/>
           </a:p>
@@ -13983,7 +13983,7 @@
                 <a:ea typeface="Calibri" pitchFamily="34" charset="-122"/>
                 <a:cs typeface="Calibri" pitchFamily="34" charset="-120"/>
               </a:rPr>
-              <a:t>Surya Nalluri · Aluri</a:t>
+              <a:t>Surya Nalluri</a:t>
             </a:r>
             <a:endParaRPr lang="en-US" sz="900" dirty="0"/>
           </a:p>
@@ -16735,7 +16735,7 @@
                 <a:ea typeface="Calibri" pitchFamily="34" charset="-122"/>
                 <a:cs typeface="Calibri" pitchFamily="34" charset="-120"/>
               </a:rPr>
-              <a:t>Surya Nalluri · Aluri</a:t>
+              <a:t>Surya Nalluri</a:t>
             </a:r>
             <a:endParaRPr lang="en-US" sz="900" dirty="0"/>
           </a:p>
@@ -17814,7 +17814,7 @@
                 <a:ea typeface="Calibri" pitchFamily="34" charset="-122"/>
                 <a:cs typeface="Calibri" pitchFamily="34" charset="-120"/>
               </a:rPr>
-              <a:t>Surya Nalluri · Aluri</a:t>
+              <a:t>Surya Nalluri</a:t>
             </a:r>
             <a:endParaRPr lang="en-US" sz="900" dirty="0"/>
           </a:p>

</xml_diff>